<commit_message>
deleted pp by mistake, updating
</commit_message>
<xml_diff>
--- a/topic03-dataTypes-variables-and-expressions/unit-1/talk-2/b-local-vars.pptx
+++ b/topic03-dataTypes-variables-and-expressions/unit-1/talk-2/b-local-vars.pptx
@@ -492,14 +492,14 @@
           </a:ln>
           <a:extLst>
             <a:ext uri="{909E8E84-426E-40dd-AFC4-6F175D3DCCD1}">
-              <a14:hiddenFill xmlns="" xmlns:a14="http://schemas.microsoft.com/office/drawing/2010/main">
+              <a14:hiddenFill xmlns:a14="http://schemas.microsoft.com/office/drawing/2010/main" xmlns="">
                 <a:solidFill>
                   <a:srgbClr val="FFFFFF"/>
                 </a:solidFill>
               </a14:hiddenFill>
             </a:ext>
             <a:ext uri="{FAA26D3D-D897-4be2-8F04-BA451C77F1D7}">
-              <ma14:placeholderFlag xmlns="" xmlns:ma14="http://schemas.microsoft.com/office/mac/drawingml/2011/main" val="1"/>
+              <ma14:placeholderFlag xmlns:ma14="http://schemas.microsoft.com/office/mac/drawingml/2011/main" xmlns="" val="1"/>
             </a:ext>
           </a:extLst>
         </p:spPr>
@@ -843,14 +843,14 @@
           <a:noFill/>
           <a:extLst>
             <a:ext uri="{909E8E84-426E-40dd-AFC4-6F175D3DCCD1}">
-              <a14:hiddenFill xmlns="" xmlns:a14="http://schemas.microsoft.com/office/drawing/2010/main">
+              <a14:hiddenFill xmlns:a14="http://schemas.microsoft.com/office/drawing/2010/main" xmlns="">
                 <a:solidFill>
                   <a:srgbClr val="FFFFFF"/>
                 </a:solidFill>
               </a14:hiddenFill>
             </a:ext>
             <a:ext uri="{91240B29-F687-4f45-9708-019B960494DF}">
-              <a14:hiddenLine xmlns="" xmlns:a14="http://schemas.microsoft.com/office/drawing/2010/main" w="9525">
+              <a14:hiddenLine xmlns:a14="http://schemas.microsoft.com/office/drawing/2010/main" xmlns="" w="9525">
                 <a:solidFill>
                   <a:srgbClr val="000000"/>
                 </a:solidFill>
@@ -998,14 +998,14 @@
           <a:noFill/>
           <a:extLst>
             <a:ext uri="{909E8E84-426E-40dd-AFC4-6F175D3DCCD1}">
-              <a14:hiddenFill xmlns="" xmlns:a14="http://schemas.microsoft.com/office/drawing/2010/main">
+              <a14:hiddenFill xmlns:a14="http://schemas.microsoft.com/office/drawing/2010/main" xmlns="">
                 <a:solidFill>
                   <a:srgbClr val="FFFFFF"/>
                 </a:solidFill>
               </a14:hiddenFill>
             </a:ext>
             <a:ext uri="{91240B29-F687-4f45-9708-019B960494DF}">
-              <a14:hiddenLine xmlns="" xmlns:a14="http://schemas.microsoft.com/office/drawing/2010/main" w="9525">
+              <a14:hiddenLine xmlns:a14="http://schemas.microsoft.com/office/drawing/2010/main" xmlns="" w="9525">
                 <a:solidFill>
                   <a:srgbClr val="000000"/>
                 </a:solidFill>
@@ -1153,14 +1153,14 @@
           <a:noFill/>
           <a:extLst>
             <a:ext uri="{909E8E84-426E-40dd-AFC4-6F175D3DCCD1}">
-              <a14:hiddenFill xmlns="" xmlns:a14="http://schemas.microsoft.com/office/drawing/2010/main">
+              <a14:hiddenFill xmlns:a14="http://schemas.microsoft.com/office/drawing/2010/main" xmlns="">
                 <a:solidFill>
                   <a:srgbClr val="FFFFFF"/>
                 </a:solidFill>
               </a14:hiddenFill>
             </a:ext>
             <a:ext uri="{91240B29-F687-4f45-9708-019B960494DF}">
-              <a14:hiddenLine xmlns="" xmlns:a14="http://schemas.microsoft.com/office/drawing/2010/main" w="9525">
+              <a14:hiddenLine xmlns:a14="http://schemas.microsoft.com/office/drawing/2010/main" xmlns="" w="9525">
                 <a:solidFill>
                   <a:srgbClr val="000000"/>
                 </a:solidFill>
@@ -1332,7 +1332,7 @@
         <p:spPr>
           <a:extLst>
             <a:ext uri="{FAA26D3D-D897-4be2-8F04-BA451C77F1D7}">
-              <ma14:placeholderFlag xmlns="" xmlns:ma14="http://schemas.microsoft.com/office/mac/drawingml/2011/main" val="1"/>
+              <ma14:placeholderFlag xmlns:ma14="http://schemas.microsoft.com/office/mac/drawingml/2011/main" xmlns="" val="1"/>
             </a:ext>
           </a:extLst>
         </p:spPr>
@@ -1394,14 +1394,14 @@
           <a:noFill/>
           <a:extLst>
             <a:ext uri="{909E8E84-426E-40dd-AFC4-6F175D3DCCD1}">
-              <a14:hiddenFill xmlns="" xmlns:a14="http://schemas.microsoft.com/office/drawing/2010/main">
+              <a14:hiddenFill xmlns:a14="http://schemas.microsoft.com/office/drawing/2010/main" xmlns="">
                 <a:solidFill>
                   <a:srgbClr val="FFFFFF"/>
                 </a:solidFill>
               </a14:hiddenFill>
             </a:ext>
             <a:ext uri="{91240B29-F687-4f45-9708-019B960494DF}">
-              <a14:hiddenLine xmlns="" xmlns:a14="http://schemas.microsoft.com/office/drawing/2010/main" w="9525">
+              <a14:hiddenLine xmlns:a14="http://schemas.microsoft.com/office/drawing/2010/main" xmlns="" w="9525">
                 <a:solidFill>
                   <a:srgbClr val="000000"/>
                 </a:solidFill>
@@ -1549,14 +1549,14 @@
           <a:noFill/>
           <a:extLst>
             <a:ext uri="{909E8E84-426E-40dd-AFC4-6F175D3DCCD1}">
-              <a14:hiddenFill xmlns="" xmlns:a14="http://schemas.microsoft.com/office/drawing/2010/main">
+              <a14:hiddenFill xmlns:a14="http://schemas.microsoft.com/office/drawing/2010/main" xmlns="">
                 <a:solidFill>
                   <a:srgbClr val="FFFFFF"/>
                 </a:solidFill>
               </a14:hiddenFill>
             </a:ext>
             <a:ext uri="{91240B29-F687-4f45-9708-019B960494DF}">
-              <a14:hiddenLine xmlns="" xmlns:a14="http://schemas.microsoft.com/office/drawing/2010/main" w="9525">
+              <a14:hiddenLine xmlns:a14="http://schemas.microsoft.com/office/drawing/2010/main" xmlns="" w="9525">
                 <a:solidFill>
                   <a:srgbClr val="000000"/>
                 </a:solidFill>
@@ -1704,14 +1704,14 @@
           <a:noFill/>
           <a:extLst>
             <a:ext uri="{909E8E84-426E-40dd-AFC4-6F175D3DCCD1}">
-              <a14:hiddenFill xmlns="" xmlns:a14="http://schemas.microsoft.com/office/drawing/2010/main">
+              <a14:hiddenFill xmlns:a14="http://schemas.microsoft.com/office/drawing/2010/main" xmlns="">
                 <a:solidFill>
                   <a:srgbClr val="FFFFFF"/>
                 </a:solidFill>
               </a14:hiddenFill>
             </a:ext>
             <a:ext uri="{91240B29-F687-4f45-9708-019B960494DF}">
-              <a14:hiddenLine xmlns="" xmlns:a14="http://schemas.microsoft.com/office/drawing/2010/main" w="9525">
+              <a14:hiddenLine xmlns:a14="http://schemas.microsoft.com/office/drawing/2010/main" xmlns="" w="9525">
                 <a:solidFill>
                   <a:srgbClr val="000000"/>
                 </a:solidFill>
@@ -1891,14 +1891,14 @@
           <a:noFill/>
           <a:extLst>
             <a:ext uri="{909E8E84-426E-40dd-AFC4-6F175D3DCCD1}">
-              <a14:hiddenFill xmlns="" xmlns:a14="http://schemas.microsoft.com/office/drawing/2010/main">
+              <a14:hiddenFill xmlns:a14="http://schemas.microsoft.com/office/drawing/2010/main" xmlns="">
                 <a:solidFill>
                   <a:srgbClr val="FFFFFF"/>
                 </a:solidFill>
               </a14:hiddenFill>
             </a:ext>
             <a:ext uri="{91240B29-F687-4f45-9708-019B960494DF}">
-              <a14:hiddenLine xmlns="" xmlns:a14="http://schemas.microsoft.com/office/drawing/2010/main" w="9525">
+              <a14:hiddenLine xmlns:a14="http://schemas.microsoft.com/office/drawing/2010/main" xmlns="" w="9525">
                 <a:solidFill>
                   <a:srgbClr val="000000"/>
                 </a:solidFill>
@@ -1908,7 +1908,7 @@
               </a14:hiddenLine>
             </a:ext>
             <a:ext uri="{AF507438-7753-43e0-B8FC-AC1667EBCBE1}">
-              <a14:hiddenEffects xmlns="" xmlns:a14="http://schemas.microsoft.com/office/drawing/2010/main">
+              <a14:hiddenEffects xmlns:a14="http://schemas.microsoft.com/office/drawing/2010/main" xmlns="">
                 <a:effectLst>
                   <a:outerShdw dist="35921" dir="2700000" algn="ctr" rotWithShape="0">
                     <a:srgbClr val="808080"/>
@@ -1917,7 +1917,7 @@
               </a14:hiddenEffects>
             </a:ext>
             <a:ext uri="{53640926-AAD7-44d8-BBD7-CCE9431645EC}">
-              <a14:shadowObscured xmlns="" xmlns:a14="http://schemas.microsoft.com/office/drawing/2010/main" val="1"/>
+              <a14:shadowObscured xmlns:a14="http://schemas.microsoft.com/office/drawing/2010/main" xmlns="" val="1"/>
             </a:ext>
           </a:extLst>
         </p:spPr>
@@ -1990,14 +1990,14 @@
           <a:noFill/>
           <a:extLst>
             <a:ext uri="{909E8E84-426E-40dd-AFC4-6F175D3DCCD1}">
-              <a14:hiddenFill xmlns="" xmlns:a14="http://schemas.microsoft.com/office/drawing/2010/main">
+              <a14:hiddenFill xmlns:a14="http://schemas.microsoft.com/office/drawing/2010/main" xmlns="">
                 <a:solidFill>
                   <a:srgbClr val="FFFFFF"/>
                 </a:solidFill>
               </a14:hiddenFill>
             </a:ext>
             <a:ext uri="{91240B29-F687-4f45-9708-019B960494DF}">
-              <a14:hiddenLine xmlns="" xmlns:a14="http://schemas.microsoft.com/office/drawing/2010/main" w="9525">
+              <a14:hiddenLine xmlns:a14="http://schemas.microsoft.com/office/drawing/2010/main" xmlns="" w="9525">
                 <a:solidFill>
                   <a:srgbClr val="000000"/>
                 </a:solidFill>
@@ -2145,14 +2145,14 @@
           <a:noFill/>
           <a:extLst>
             <a:ext uri="{909E8E84-426E-40dd-AFC4-6F175D3DCCD1}">
-              <a14:hiddenFill xmlns="" xmlns:a14="http://schemas.microsoft.com/office/drawing/2010/main">
+              <a14:hiddenFill xmlns:a14="http://schemas.microsoft.com/office/drawing/2010/main" xmlns="">
                 <a:solidFill>
                   <a:srgbClr val="FFFFFF"/>
                 </a:solidFill>
               </a14:hiddenFill>
             </a:ext>
             <a:ext uri="{91240B29-F687-4f45-9708-019B960494DF}">
-              <a14:hiddenLine xmlns="" xmlns:a14="http://schemas.microsoft.com/office/drawing/2010/main" w="9525">
+              <a14:hiddenLine xmlns:a14="http://schemas.microsoft.com/office/drawing/2010/main" xmlns="" w="9525">
                 <a:solidFill>
                   <a:srgbClr val="000000"/>
                 </a:solidFill>
@@ -2300,14 +2300,14 @@
           <a:noFill/>
           <a:extLst>
             <a:ext uri="{909E8E84-426E-40dd-AFC4-6F175D3DCCD1}">
-              <a14:hiddenFill xmlns="" xmlns:a14="http://schemas.microsoft.com/office/drawing/2010/main">
+              <a14:hiddenFill xmlns:a14="http://schemas.microsoft.com/office/drawing/2010/main" xmlns="">
                 <a:solidFill>
                   <a:srgbClr val="FFFFFF"/>
                 </a:solidFill>
               </a14:hiddenFill>
             </a:ext>
             <a:ext uri="{91240B29-F687-4f45-9708-019B960494DF}">
-              <a14:hiddenLine xmlns="" xmlns:a14="http://schemas.microsoft.com/office/drawing/2010/main" w="9525">
+              <a14:hiddenLine xmlns:a14="http://schemas.microsoft.com/office/drawing/2010/main" xmlns="" w="9525">
                 <a:solidFill>
                   <a:srgbClr val="000000"/>
                 </a:solidFill>
@@ -2479,7 +2479,7 @@
         <p:spPr>
           <a:extLst>
             <a:ext uri="{FAA26D3D-D897-4be2-8F04-BA451C77F1D7}">
-              <ma14:placeholderFlag xmlns="" xmlns:ma14="http://schemas.microsoft.com/office/mac/drawingml/2011/main" val="1"/>
+              <ma14:placeholderFlag xmlns:ma14="http://schemas.microsoft.com/office/mac/drawingml/2011/main" xmlns="" val="1"/>
             </a:ext>
           </a:extLst>
         </p:spPr>
@@ -2681,14 +2681,14 @@
           <a:noFill/>
           <a:extLst>
             <a:ext uri="{909E8E84-426E-40dd-AFC4-6F175D3DCCD1}">
-              <a14:hiddenFill xmlns="" xmlns:a14="http://schemas.microsoft.com/office/drawing/2010/main">
+              <a14:hiddenFill xmlns:a14="http://schemas.microsoft.com/office/drawing/2010/main" xmlns="">
                 <a:solidFill>
                   <a:srgbClr val="FFFFFF"/>
                 </a:solidFill>
               </a14:hiddenFill>
             </a:ext>
             <a:ext uri="{91240B29-F687-4f45-9708-019B960494DF}">
-              <a14:hiddenLine xmlns="" xmlns:a14="http://schemas.microsoft.com/office/drawing/2010/main" w="9525">
+              <a14:hiddenLine xmlns:a14="http://schemas.microsoft.com/office/drawing/2010/main" xmlns="" w="9525">
                 <a:solidFill>
                   <a:srgbClr val="000000"/>
                 </a:solidFill>
@@ -2836,14 +2836,14 @@
           <a:noFill/>
           <a:extLst>
             <a:ext uri="{909E8E84-426E-40dd-AFC4-6F175D3DCCD1}">
-              <a14:hiddenFill xmlns="" xmlns:a14="http://schemas.microsoft.com/office/drawing/2010/main">
+              <a14:hiddenFill xmlns:a14="http://schemas.microsoft.com/office/drawing/2010/main" xmlns="">
                 <a:solidFill>
                   <a:srgbClr val="FFFFFF"/>
                 </a:solidFill>
               </a14:hiddenFill>
             </a:ext>
             <a:ext uri="{91240B29-F687-4f45-9708-019B960494DF}">
-              <a14:hiddenLine xmlns="" xmlns:a14="http://schemas.microsoft.com/office/drawing/2010/main" w="9525">
+              <a14:hiddenLine xmlns:a14="http://schemas.microsoft.com/office/drawing/2010/main" xmlns="" w="9525">
                 <a:solidFill>
                   <a:srgbClr val="000000"/>
                 </a:solidFill>
@@ -2991,14 +2991,14 @@
           <a:noFill/>
           <a:extLst>
             <a:ext uri="{909E8E84-426E-40dd-AFC4-6F175D3DCCD1}">
-              <a14:hiddenFill xmlns="" xmlns:a14="http://schemas.microsoft.com/office/drawing/2010/main">
+              <a14:hiddenFill xmlns:a14="http://schemas.microsoft.com/office/drawing/2010/main" xmlns="">
                 <a:solidFill>
                   <a:srgbClr val="FFFFFF"/>
                 </a:solidFill>
               </a14:hiddenFill>
             </a:ext>
             <a:ext uri="{91240B29-F687-4f45-9708-019B960494DF}">
-              <a14:hiddenLine xmlns="" xmlns:a14="http://schemas.microsoft.com/office/drawing/2010/main" w="9525">
+              <a14:hiddenLine xmlns:a14="http://schemas.microsoft.com/office/drawing/2010/main" xmlns="" w="9525">
                 <a:solidFill>
                   <a:srgbClr val="000000"/>
                 </a:solidFill>
@@ -3184,7 +3184,7 @@
           </a:ln>
           <a:extLst>
             <a:ext uri="{FAA26D3D-D897-4be2-8F04-BA451C77F1D7}">
-              <ma14:placeholderFlag xmlns="" xmlns:ma14="http://schemas.microsoft.com/office/mac/drawingml/2011/main" val="1"/>
+              <ma14:placeholderFlag xmlns:ma14="http://schemas.microsoft.com/office/mac/drawingml/2011/main" xmlns="" val="1"/>
             </a:ext>
           </a:extLst>
         </p:spPr>
@@ -3396,7 +3396,7 @@
           <a:p>
             <a:fld id="{C764DE79-268F-4C1A-8933-263129D2AF90}" type="datetimeFigureOut">
               <a:rPr lang="en-US" smtClean="0"/>
-              <a:t>9/28/25</a:t>
+              <a:t>10/6/2025</a:t>
             </a:fld>
             <a:endParaRPr lang="en-US" dirty="0"/>
           </a:p>
@@ -3567,7 +3567,7 @@
           <a:p>
             <a:fld id="{C764DE79-268F-4C1A-8933-263129D2AF90}" type="datetimeFigureOut">
               <a:rPr lang="en-US" smtClean="0"/>
-              <a:t>9/28/25</a:t>
+              <a:t>10/6/2025</a:t>
             </a:fld>
             <a:endParaRPr lang="en-US" dirty="0"/>
           </a:p>
@@ -3748,7 +3748,7 @@
           <a:p>
             <a:fld id="{C764DE79-268F-4C1A-8933-263129D2AF90}" type="datetimeFigureOut">
               <a:rPr lang="en-US" smtClean="0"/>
-              <a:t>9/28/25</a:t>
+              <a:t>10/6/2025</a:t>
             </a:fld>
             <a:endParaRPr lang="en-US" dirty="0"/>
           </a:p>
@@ -4479,7 +4479,7 @@
           <a:p>
             <a:fld id="{C764DE79-268F-4C1A-8933-263129D2AF90}" type="datetimeFigureOut">
               <a:rPr lang="en-US" smtClean="0"/>
-              <a:t>9/28/25</a:t>
+              <a:t>10/6/2025</a:t>
             </a:fld>
             <a:endParaRPr lang="en-US" dirty="0"/>
           </a:p>
@@ -4851,7 +4851,7 @@
           <a:p>
             <a:fld id="{C764DE79-268F-4C1A-8933-263129D2AF90}" type="datetimeFigureOut">
               <a:rPr lang="en-US" smtClean="0"/>
-              <a:t>9/28/25</a:t>
+              <a:t>10/6/2025</a:t>
             </a:fld>
             <a:endParaRPr lang="en-US" dirty="0"/>
           </a:p>
@@ -5151,7 +5151,7 @@
           <a:p>
             <a:fld id="{C764DE79-268F-4C1A-8933-263129D2AF90}" type="datetimeFigureOut">
               <a:rPr lang="en-US" smtClean="0"/>
-              <a:t>9/28/25</a:t>
+              <a:t>10/6/2025</a:t>
             </a:fld>
             <a:endParaRPr lang="en-US" dirty="0"/>
           </a:p>
@@ -5698,7 +5698,7 @@
           <a:p>
             <a:fld id="{C764DE79-268F-4C1A-8933-263129D2AF90}" type="datetimeFigureOut">
               <a:rPr lang="en-US" smtClean="0"/>
-              <a:t>9/28/25</a:t>
+              <a:t>10/6/2025</a:t>
             </a:fld>
             <a:endParaRPr lang="en-US" dirty="0"/>
           </a:p>
@@ -5904,7 +5904,7 @@
           <a:p>
             <a:fld id="{C764DE79-268F-4C1A-8933-263129D2AF90}" type="datetimeFigureOut">
               <a:rPr lang="en-US" smtClean="0"/>
-              <a:t>9/28/25</a:t>
+              <a:t>10/6/2025</a:t>
             </a:fld>
             <a:endParaRPr lang="en-US" dirty="0"/>
           </a:p>
@@ -6116,7 +6116,7 @@
           <a:p>
             <a:fld id="{C764DE79-268F-4C1A-8933-263129D2AF90}" type="datetimeFigureOut">
               <a:rPr lang="en-US" smtClean="0"/>
-              <a:t>9/28/25</a:t>
+              <a:t>10/6/2025</a:t>
             </a:fld>
             <a:endParaRPr lang="en-US" dirty="0"/>
           </a:p>
@@ -6393,7 +6393,7 @@
           <a:p>
             <a:fld id="{C764DE79-268F-4C1A-8933-263129D2AF90}" type="datetimeFigureOut">
               <a:rPr lang="en-US" smtClean="0"/>
-              <a:t>9/28/25</a:t>
+              <a:t>10/6/2025</a:t>
             </a:fld>
             <a:endParaRPr lang="en-US" dirty="0"/>
           </a:p>
@@ -6651,7 +6651,7 @@
           <a:p>
             <a:fld id="{C764DE79-268F-4C1A-8933-263129D2AF90}" type="datetimeFigureOut">
               <a:rPr lang="en-US" smtClean="0"/>
-              <a:t>9/28/25</a:t>
+              <a:t>10/6/2025</a:t>
             </a:fld>
             <a:endParaRPr lang="en-US" dirty="0"/>
           </a:p>
@@ -6870,7 +6870,7 @@
           <a:p>
             <a:fld id="{C764DE79-268F-4C1A-8933-263129D2AF90}" type="datetimeFigureOut">
               <a:rPr lang="en-US" smtClean="0"/>
-              <a:t>9/28/25</a:t>
+              <a:t>10/6/2025</a:t>
             </a:fld>
             <a:endParaRPr lang="en-US" dirty="0"/>
           </a:p>
@@ -7339,14 +7339,14 @@
           </a:ln>
           <a:extLst>
             <a:ext uri="{909E8E84-426E-40dd-AFC4-6F175D3DCCD1}">
-              <a14:hiddenFill xmlns="" xmlns:a14="http://schemas.microsoft.com/office/drawing/2010/main">
+              <a14:hiddenFill xmlns:a14="http://schemas.microsoft.com/office/drawing/2010/main" xmlns="">
                 <a:solidFill>
                   <a:srgbClr val="FFFFFF"/>
                 </a:solidFill>
               </a14:hiddenFill>
             </a:ext>
             <a:ext uri="{91240B29-F687-4f45-9708-019B960494DF}">
-              <a14:hiddenLine xmlns="" xmlns:a14="http://schemas.microsoft.com/office/drawing/2010/main" w="9525">
+              <a14:hiddenLine xmlns:a14="http://schemas.microsoft.com/office/drawing/2010/main" xmlns="" w="9525">
                 <a:solidFill>
                   <a:srgbClr val="000000"/>
                 </a:solidFill>
@@ -9709,14 +9709,14 @@
           </a:ln>
           <a:extLst>
             <a:ext uri="{909E8E84-426E-40dd-AFC4-6F175D3DCCD1}">
-              <a14:hiddenFill xmlns="" xmlns:a14="http://schemas.microsoft.com/office/drawing/2010/main">
+              <a14:hiddenFill xmlns:a14="http://schemas.microsoft.com/office/drawing/2010/main" xmlns="">
                 <a:solidFill>
                   <a:srgbClr val="FFFFFF"/>
                 </a:solidFill>
               </a14:hiddenFill>
             </a:ext>
             <a:ext uri="{91240B29-F687-4f45-9708-019B960494DF}">
-              <a14:hiddenLine xmlns="" xmlns:a14="http://schemas.microsoft.com/office/drawing/2010/main" w="9525">
+              <a14:hiddenLine xmlns:a14="http://schemas.microsoft.com/office/drawing/2010/main" xmlns="" w="9525">
                 <a:solidFill>
                   <a:srgbClr val="000000"/>
                 </a:solidFill>
@@ -10541,14 +10541,14 @@
           </a:ln>
           <a:extLst>
             <a:ext uri="{909E8E84-426E-40dd-AFC4-6F175D3DCCD1}">
-              <a14:hiddenFill xmlns="" xmlns:a14="http://schemas.microsoft.com/office/drawing/2010/main">
+              <a14:hiddenFill xmlns:a14="http://schemas.microsoft.com/office/drawing/2010/main" xmlns="">
                 <a:solidFill>
                   <a:srgbClr val="FFFFFF"/>
                 </a:solidFill>
               </a14:hiddenFill>
             </a:ext>
             <a:ext uri="{91240B29-F687-4f45-9708-019B960494DF}">
-              <a14:hiddenLine xmlns="" xmlns:a14="http://schemas.microsoft.com/office/drawing/2010/main" w="9525">
+              <a14:hiddenLine xmlns:a14="http://schemas.microsoft.com/office/drawing/2010/main" xmlns="" w="9525">
                 <a:solidFill>
                   <a:srgbClr val="000000"/>
                 </a:solidFill>
@@ -10969,14 +10969,14 @@
           </a:ln>
           <a:extLst>
             <a:ext uri="{909E8E84-426E-40dd-AFC4-6F175D3DCCD1}">
-              <a14:hiddenFill xmlns="" xmlns:a14="http://schemas.microsoft.com/office/drawing/2010/main">
+              <a14:hiddenFill xmlns:a14="http://schemas.microsoft.com/office/drawing/2010/main" xmlns="">
                 <a:solidFill>
                   <a:srgbClr val="FFFFFF"/>
                 </a:solidFill>
               </a14:hiddenFill>
             </a:ext>
             <a:ext uri="{91240B29-F687-4f45-9708-019B960494DF}">
-              <a14:hiddenLine xmlns="" xmlns:a14="http://schemas.microsoft.com/office/drawing/2010/main" w="9525">
+              <a14:hiddenLine xmlns:a14="http://schemas.microsoft.com/office/drawing/2010/main" xmlns="" w="9525">
                 <a:solidFill>
                   <a:srgbClr val="000000"/>
                 </a:solidFill>
@@ -11334,14 +11334,14 @@
           </a:ln>
           <a:extLst>
             <a:ext uri="{909E8E84-426E-40dd-AFC4-6F175D3DCCD1}">
-              <a14:hiddenFill xmlns="" xmlns:a14="http://schemas.microsoft.com/office/drawing/2010/main">
+              <a14:hiddenFill xmlns:a14="http://schemas.microsoft.com/office/drawing/2010/main" xmlns="">
                 <a:solidFill>
                   <a:srgbClr val="FFFFFF"/>
                 </a:solidFill>
               </a14:hiddenFill>
             </a:ext>
             <a:ext uri="{91240B29-F687-4f45-9708-019B960494DF}">
-              <a14:hiddenLine xmlns="" xmlns:a14="http://schemas.microsoft.com/office/drawing/2010/main" w="9525">
+              <a14:hiddenLine xmlns:a14="http://schemas.microsoft.com/office/drawing/2010/main" xmlns="" w="9525">
                 <a:solidFill>
                   <a:srgbClr val="000000"/>
                 </a:solidFill>
@@ -11582,7 +11582,7 @@
           </a:ln>
           <a:extLst>
             <a:ext uri="{909E8E84-426E-40dd-AFC4-6F175D3DCCD1}">
-              <a14:hiddenFill xmlns="" xmlns:a14="http://schemas.microsoft.com/office/drawing/2010/main">
+              <a14:hiddenFill xmlns:a14="http://schemas.microsoft.com/office/drawing/2010/main" xmlns="">
                 <a:noFill/>
               </a14:hiddenFill>
             </a:ext>

</xml_diff>